<commit_message>
Update presentation: replace all DigitalOcean references with Azure
</commit_message>
<xml_diff>
--- a/docs/ChitChat_Presentation.pptx
+++ b/docs/ChitChat_Presentation.pptx
@@ -3676,7 +3676,7 @@
                 </a:solidFill>
                 <a:latin typeface="Source Sans Pro"/>
               </a:rPr>
-              <a:t>https://chitchat-pidj7.ondigitalocean.app</a:t>
+              <a:t>https://chitchat-dwhqarhneuf7grb8.canadacentral-01.azurewebsites.net</a:t>
             </a:r>
           </a:p>
         </p:txBody>
@@ -4217,7 +4217,7 @@
                 </a:solidFill>
                 <a:latin typeface="Source Sans Pro"/>
               </a:rPr>
-              <a:t>Schema design, JPA entities, Maven config, DigitalOcean deployment, integration testing, documentation</a:t>
+              <a:t>Schema design, JPA entities, Maven config, Azure deployment, integration testing, documentation</a:t>
             </a:r>
           </a:p>
         </p:txBody>
@@ -9745,7 +9745,7 @@
                 <a:latin typeface="Source Sans Pro"/>
                 <a:ea typeface="Source Sans Pro"/>
               </a:rPr>
-              <a:t>Live on DigitalOcean with managed PostgreSQL database</a:t>
+              <a:t>Live on Microsoft Azure App Service with PostgreSQL</a:t>
             </a:r>
           </a:p>
         </p:txBody>
@@ -10393,7 +10393,7 @@
                 <a:latin typeface="Source Sans Pro"/>
                 <a:ea typeface="Source Sans Pro"/>
               </a:rPr>
-              <a:t>https://chitchat-pidj7.ondigitalocean.app</a:t>
+              <a:t>https://chitchat-dwhqarhneuf7grb8.canadacentral-01.azurewebsites.net</a:t>
             </a:r>
           </a:p>
         </p:txBody>
@@ -11468,7 +11468,7 @@
                 </a:solidFill>
                 <a:latin typeface="Source Sans Pro"/>
               </a:rPr>
-              <a:t> — migrating from MySQL to PostgreSQL on DigitalOcean App Platform</a:t>
+              <a:t> — migrating from MySQL to PostgreSQL on Azure App Service + GitHub Actions CI/CD</a:t>
             </a:r>
           </a:p>
           <a:p>
@@ -11775,7 +11775,7 @@
                 </a:solidFill>
                 <a:latin typeface="Source Sans Pro"/>
               </a:rPr>
-              <a:t> — deploying to DigitalOcean from week 1 caught environment-specific issues</a:t>
+              <a:t> — deploying to Azure from week 1 caught environment-specific issues</a:t>
             </a:r>
           </a:p>
           <a:p>
@@ -12608,7 +12608,7 @@
                 <a:latin typeface="Source Sans Pro"/>
                 <a:ea typeface="Source Sans Pro"/>
               </a:rPr>
-              <a:t>[7]  DigitalOcean App Platform</a:t>
+              <a:t>[7]  Microsoft Azure App Service</a:t>
             </a:r>
           </a:p>
         </p:txBody>
@@ -12650,7 +12650,7 @@
                 <a:latin typeface="Source Sans Pro"/>
                 <a:ea typeface="Source Sans Pro"/>
               </a:rPr>
-              <a:t>docs.digitalocean.com/products/app-platform</a:t>
+              <a:t>learn.microsoft.com/azure/app-service</a:t>
             </a:r>
           </a:p>
         </p:txBody>

</xml_diff>